<commit_message>
docs: project complete — roadmap closed, README cleaned, final deck updated
Roadmap: every phase and loose end closed (Copilot packet and panel,
production reseed after a backup, eval 22/22); "Left to do" is now
"Closing phases (all complete)". README: the placeholder TODOs, the
never-built Python ml-hotspots prerequisite and the empty GitHub column
are gone. Final deck: the Copilot slide shows the restyled panel answering
"where are the hotspots?" and the 22/22 run; the status slide's next steps
drop the Copilot item. The superseded 22 Oct pitch deck, PDF and script are
removed (in git history at 6f57707).
</commit_message>
<xml_diff>
--- a/presentation/CivicPulse-final.pptx
+++ b/presentation/CivicPulse-final.pptx
@@ -140,18 +140,18 @@
   <p:extLst>
     <p:ext uri="{521415D9-36F7-43E2-AB2F-B90AF26B5E84}">
       <p14:sectionLst xmlns:p14="http://schemas.microsoft.com/office/powerpoint/2010/main">
-        <p14:section name="Opening" id="{A7540DBC-49BA-86B7-8FA2-4D0AB066A748}">
+        <p14:section name="Opening" id="{171F9030-7840-5A1E-A899-730A69278AA7}">
           <p14:sldIdLst>
             <p14:sldId id="256"/>
           </p14:sldIdLst>
         </p14:section>
-        <p14:section name="Problem and solution" id="{52F2CB7A-CBC8-CF9F-3362-97B0D70CD879}">
+        <p14:section name="Problem and solution" id="{4B3A9A82-8F7E-2B11-6017-CFADF9C8829B}">
           <p14:sldIdLst>
             <p14:sldId id="257"/>
             <p14:sldId id="258"/>
           </p14:sldIdLst>
         </p14:section>
-        <p14:section name="How it works" id="{C5C92DD5-0771-8101-C2FB-492C1E8A75AF}">
+        <p14:section name="How it works" id="{CC4AAFDD-F6F8-6F28-DBE3-60A5A9D4D565}">
           <p14:sldIdLst>
             <p14:sldId id="259"/>
             <p14:sldId id="260"/>
@@ -161,7 +161,7 @@
             <p14:sldId id="264"/>
           </p14:sldIdLst>
         </p14:section>
-        <p14:section name="Results and next steps" id="{CE7A5C93-7566-20BC-15D0-DC20367153FA}">
+        <p14:section name="Results and next steps" id="{7BFBC30F-B0DB-67C5-28B6-234700638433}">
           <p14:sldIdLst>
             <p14:sldId id="265"/>
             <p14:sldId id="266"/>
@@ -327,7 +327,7 @@
           <c:smooth val="0"/>
           <c:extLst>
             <c:ext xmlns:c16="http://schemas.microsoft.com/office/drawing/2014/chart" uri="{C3380CC4-5D6E-409C-BE32-E72D297353CC}">
-              <c16:uniqueId val="{00000000-0CA2-4CD6-8954-0BA42BE0C260}"/>
+              <c16:uniqueId val="{00000000-9DFC-43D8-A10A-553156EC3EF7}"/>
             </c:ext>
           </c:extLst>
         </c:ser>
@@ -440,7 +440,7 @@
           <c:smooth val="0"/>
           <c:extLst>
             <c:ext xmlns:c16="http://schemas.microsoft.com/office/drawing/2014/chart" uri="{C3380CC4-5D6E-409C-BE32-E72D297353CC}">
-              <c16:uniqueId val="{00000001-0CA2-4CD6-8954-0BA42BE0C260}"/>
+              <c16:uniqueId val="{00000001-9DFC-43D8-A10A-553156EC3EF7}"/>
             </c:ext>
           </c:extLst>
         </c:ser>
@@ -732,7 +732,7 @@
           </c:val>
           <c:extLst>
             <c:ext xmlns:c16="http://schemas.microsoft.com/office/drawing/2014/chart" uri="{C3380CC4-5D6E-409C-BE32-E72D297353CC}">
-              <c16:uniqueId val="{00000000-CE83-4AEF-BD7E-8ECC9722D61D}"/>
+              <c16:uniqueId val="{00000000-98FB-4633-810B-8F58BB5B0952}"/>
             </c:ext>
           </c:extLst>
         </c:ser>
@@ -831,7 +831,7 @@
           </c:val>
           <c:extLst>
             <c:ext xmlns:c16="http://schemas.microsoft.com/office/drawing/2014/chart" uri="{C3380CC4-5D6E-409C-BE32-E72D297353CC}">
-              <c16:uniqueId val="{00000001-CE83-4AEF-BD7E-8ECC9722D61D}"/>
+              <c16:uniqueId val="{00000001-98FB-4633-810B-8F58BB5B0952}"/>
             </c:ext>
           </c:extLst>
         </c:ser>
@@ -930,7 +930,7 @@
           </c:val>
           <c:extLst>
             <c:ext xmlns:c16="http://schemas.microsoft.com/office/drawing/2014/chart" uri="{C3380CC4-5D6E-409C-BE32-E72D297353CC}">
-              <c16:uniqueId val="{00000002-CE83-4AEF-BD7E-8ECC9722D61D}"/>
+              <c16:uniqueId val="{00000002-98FB-4633-810B-8F58BB5B0952}"/>
             </c:ext>
           </c:extLst>
         </c:ser>
@@ -1109,7 +1109,7 @@
     </p:spTree>
     <p:extLst>
       <p:ext uri="{BB962C8B-B14F-4D97-AF65-F5344CB8AC3E}">
-        <p14:creationId xmlns:p14="http://schemas.microsoft.com/office/powerpoint/2010/main" val="3932473438"/>
+        <p14:creationId xmlns:p14="http://schemas.microsoft.com/office/powerpoint/2010/main" val="3465769672"/>
       </p:ext>
     </p:extLst>
   </p:cSld>
@@ -1437,7 +1437,7 @@
               <a:rPr lang="en-US" dirty="0"/>
               <a:t>SPEAKER 4  ·  about 30 seconds
 Today, all of this is built, tested and deployed: intake, matching, priority, the console, hotspots, decision support, officer controls and the Copilot.
-Next: give the Copilot hotspots and life-safety flags, confirm the priority weights with a real officer, connect a real data feed, and add photo upload.</a:t>
+Next: confirm the priority weights with a real officer, connect a real data feed, test Kannada–English mixed text, and add photo upload.</a:t>
             </a:r>
           </a:p>
         </p:txBody>
@@ -2251,9 +2251,9 @@
             <a:r>
               <a:rPr lang="en-US" dirty="0"/>
               <a:t>SPEAKER 4  ·  about 60 seconds
-Thanks, [Speaker 3]. The Officer Copilot lets an officer ask in plain words, “which incidents are most urgent, and why?”, and get an answer built only from CivicPulse data. Every claim cites an incident, ward or category, and residents’ complaint text is never sent to the model.
-We tested it with 22 questions, including ones it should refuse: the weather, the mayor, a resident’s phone number, and “ignore your instructions”. It passed 21. Across 37 citations and 81 numbers, not one was made up: everything came from the data. It declined 8 of the 9 out-of-scope questions.
-The one miss is honest and useful: asked for hotspots, it named the busiest wards, because hotspots are not in its data yet. That is our first next step.</a:t>
+Thanks, [Speaker 3]. The Officer Copilot lets an officer ask in plain words, here “where are the hotspots right now?”, and get an answer built only from CivicPulse data. Every claim cites its source: an incident, ward, category or hotspot. Residents’ complaint text is never sent to the model.
+We tested it with 22 questions, including ones it must refuse: the weather, the mayor, a resident’s phone number, and “ignore your instructions”. It passed all 22. Across 38 citations and 81 numbers, not one was made up.
+Our first run scored 21: asked for hotspots, it named the busiest wards, because hotspots were not in its data yet. We added hotspots and life-safety flags, re-ran the test, and it answered both correctly.</a:t>
             </a:r>
           </a:p>
         </p:txBody>
@@ -4871,7 +4871,7 @@
                 <a:ea typeface="Poppins" pitchFamily="34" charset="-122"/>
                 <a:cs typeface="Poppins" pitchFamily="34" charset="-120"/>
               </a:rPr>
-              <a:t>Grounded answers, 21/22 in eval</a:t>
+              <a:t>Grounded answers, 22/22 in eval</a:t>
             </a:r>
             <a:endParaRPr lang="en-US" sz="1100" dirty="0"/>
           </a:p>
@@ -4918,7 +4918,7 @@
       </p:sp>
       <p:sp>
         <p:nvSpPr>
-          <p:cNvPr id="37" name="icon-bg LuBot"/>
+          <p:cNvPr id="37" name="icon-bg LuSparkles"/>
           <p:cNvSpPr/>
           <p:nvPr/>
         </p:nvSpPr>
@@ -4943,7 +4943,7 @@
       </p:sp>
       <p:pic>
         <p:nvPicPr>
-          <p:cNvPr id="38" name="icon LuBot" descr="preencoded.png"/>
+          <p:cNvPr id="38" name="icon LuSparkles" descr="preencoded.png"/>
           <p:cNvPicPr>
             <a:picLocks noChangeAspect="1"/>
           </p:cNvPicPr>
@@ -4998,7 +4998,7 @@
                 <a:ea typeface="Poppins SemiBold" pitchFamily="34" charset="-122"/>
                 <a:cs typeface="Poppins SemiBold" pitchFamily="34" charset="-120"/>
               </a:rPr>
-              <a:t>Copilot knows hotspots</a:t>
+              <a:t>Mixed-language text</a:t>
             </a:r>
             <a:endParaRPr lang="en-US" sz="1300" dirty="0"/>
           </a:p>
@@ -5037,7 +5037,7 @@
                 <a:ea typeface="Poppins" pitchFamily="34" charset="-122"/>
                 <a:cs typeface="Poppins" pitchFamily="34" charset="-120"/>
               </a:rPr>
-              <a:t>Add hotspots and life-safety flags to its data: the one miss in the eval.</a:t>
+              <a:t>Kannada–English reports: test transliteration before matching.</a:t>
             </a:r>
             <a:endParaRPr lang="en-US" sz="1100" dirty="0"/>
           </a:p>
@@ -12654,11 +12654,11 @@
         <p:spPr>
           <a:xfrm>
             <a:off x="548640" y="1691640"/>
-            <a:ext cx="3566160" cy="4526280"/>
+            <a:ext cx="7315200" cy="2926080"/>
           </a:xfrm>
           <a:prstGeom prst="roundRect">
             <a:avLst>
-              <a:gd name="adj" fmla="val 2051"/>
+              <a:gd name="adj" fmla="val 2500"/>
             </a:avLst>
           </a:prstGeom>
           <a:solidFill>
@@ -12688,7 +12688,7 @@
         <p:spPr>
           <a:xfrm>
             <a:off x="557784" y="1700784"/>
-            <a:ext cx="3547872" cy="274320"/>
+            <a:ext cx="7296912" cy="274320"/>
           </a:xfrm>
           <a:prstGeom prst="roundRect">
             <a:avLst>
@@ -12798,7 +12798,7 @@
         <p:spPr>
           <a:xfrm>
             <a:off x="566928" y="1975104"/>
-            <a:ext cx="3529584" cy="4224528"/>
+            <a:ext cx="7278624" cy="2624328"/>
           </a:xfrm>
           <a:prstGeom prst="rect">
             <a:avLst/>
@@ -12813,12 +12813,12 @@
         </p:nvSpPr>
         <p:spPr>
           <a:xfrm>
-            <a:off x="4526280" y="1783080"/>
-            <a:ext cx="1642034" cy="1325880"/>
+            <a:off x="8138160" y="1691640"/>
+            <a:ext cx="1661008" cy="1371600"/>
           </a:xfrm>
           <a:prstGeom prst="roundRect">
             <a:avLst>
-              <a:gd name="adj" fmla="val 6897"/>
+              <a:gd name="adj" fmla="val 6667"/>
             </a:avLst>
           </a:prstGeom>
           <a:solidFill>
@@ -12840,8 +12840,8 @@
         </p:nvSpPr>
         <p:spPr>
           <a:xfrm>
-            <a:off x="4663440" y="1874520"/>
-            <a:ext cx="1367714" cy="640080"/>
+            <a:off x="8275320" y="1783080"/>
+            <a:ext cx="1386688" cy="640080"/>
           </a:xfrm>
           <a:prstGeom prst="rect">
             <a:avLst/>
@@ -12857,7 +12857,7 @@
               <a:buNone/>
             </a:pPr>
             <a:r>
-              <a:rPr lang="en-US" sz="2600" b="1" dirty="0">
+              <a:rPr lang="en-US" sz="2400" b="1" dirty="0">
                 <a:solidFill>
                   <a:srgbClr val="17494D"/>
                 </a:solidFill>
@@ -12865,9 +12865,9 @@
                 <a:ea typeface="Playfair Display" pitchFamily="34" charset="-122"/>
                 <a:cs typeface="Playfair Display" pitchFamily="34" charset="-120"/>
               </a:rPr>
-              <a:t>21 / 22</a:t>
-            </a:r>
-            <a:endParaRPr lang="en-US" sz="2600" dirty="0"/>
+              <a:t>22 / 22</a:t>
+            </a:r>
+            <a:endParaRPr lang="en-US" sz="2400" dirty="0"/>
           </a:p>
         </p:txBody>
       </p:sp>
@@ -12879,8 +12879,8 @@
         </p:nvSpPr>
         <p:spPr>
           <a:xfrm>
-            <a:off x="4663440" y="2560320"/>
-            <a:ext cx="1367714" cy="502920"/>
+            <a:off x="8275320" y="2468880"/>
+            <a:ext cx="1386688" cy="502920"/>
           </a:xfrm>
           <a:prstGeom prst="rect">
             <a:avLst/>
@@ -12918,12 +12918,12 @@
         </p:nvSpPr>
         <p:spPr>
           <a:xfrm>
-            <a:off x="6351194" y="1783080"/>
-            <a:ext cx="1642034" cy="1325880"/>
+            <a:off x="9982048" y="1691640"/>
+            <a:ext cx="1661008" cy="1371600"/>
           </a:xfrm>
           <a:prstGeom prst="roundRect">
             <a:avLst>
-              <a:gd name="adj" fmla="val 6897"/>
+              <a:gd name="adj" fmla="val 6667"/>
             </a:avLst>
           </a:prstGeom>
           <a:solidFill>
@@ -12945,8 +12945,8 @@
         </p:nvSpPr>
         <p:spPr>
           <a:xfrm>
-            <a:off x="6488354" y="1874520"/>
-            <a:ext cx="1367714" cy="640080"/>
+            <a:off x="10119208" y="1783080"/>
+            <a:ext cx="1386688" cy="640080"/>
           </a:xfrm>
           <a:prstGeom prst="rect">
             <a:avLst/>
@@ -12962,7 +12962,7 @@
               <a:buNone/>
             </a:pPr>
             <a:r>
-              <a:rPr lang="en-US" sz="2600" b="1" dirty="0">
+              <a:rPr lang="en-US" sz="2400" b="1" dirty="0">
                 <a:solidFill>
                   <a:srgbClr val="17494D"/>
                 </a:solidFill>
@@ -12970,9 +12970,9 @@
                 <a:ea typeface="Playfair Display" pitchFamily="34" charset="-122"/>
                 <a:cs typeface="Playfair Display" pitchFamily="34" charset="-120"/>
               </a:rPr>
-              <a:t>0 of 37</a:t>
-            </a:r>
-            <a:endParaRPr lang="en-US" sz="2600" dirty="0"/>
+              <a:t>0 of 38</a:t>
+            </a:r>
+            <a:endParaRPr lang="en-US" sz="2400" dirty="0"/>
           </a:p>
         </p:txBody>
       </p:sp>
@@ -12984,8 +12984,8 @@
         </p:nvSpPr>
         <p:spPr>
           <a:xfrm>
-            <a:off x="6488354" y="2560320"/>
-            <a:ext cx="1367714" cy="502920"/>
+            <a:off x="10119208" y="2468880"/>
+            <a:ext cx="1386688" cy="502920"/>
           </a:xfrm>
           <a:prstGeom prst="rect">
             <a:avLst/>
@@ -13023,12 +13023,12 @@
         </p:nvSpPr>
         <p:spPr>
           <a:xfrm>
-            <a:off x="8176108" y="1783080"/>
-            <a:ext cx="1642034" cy="1325880"/>
+            <a:off x="8138160" y="3246120"/>
+            <a:ext cx="1661008" cy="1371600"/>
           </a:xfrm>
           <a:prstGeom prst="roundRect">
             <a:avLst>
-              <a:gd name="adj" fmla="val 6897"/>
+              <a:gd name="adj" fmla="val 6667"/>
             </a:avLst>
           </a:prstGeom>
           <a:solidFill>
@@ -13050,8 +13050,8 @@
         </p:nvSpPr>
         <p:spPr>
           <a:xfrm>
-            <a:off x="8313268" y="1874520"/>
-            <a:ext cx="1367714" cy="640080"/>
+            <a:off x="8275320" y="3337560"/>
+            <a:ext cx="1386688" cy="640080"/>
           </a:xfrm>
           <a:prstGeom prst="rect">
             <a:avLst/>
@@ -13067,7 +13067,7 @@
               <a:buNone/>
             </a:pPr>
             <a:r>
-              <a:rPr lang="en-US" sz="2600" b="1" dirty="0">
+              <a:rPr lang="en-US" sz="2400" b="1" dirty="0">
                 <a:solidFill>
                   <a:srgbClr val="17494D"/>
                 </a:solidFill>
@@ -13077,7 +13077,7 @@
               </a:rPr>
               <a:t>0 of 81</a:t>
             </a:r>
-            <a:endParaRPr lang="en-US" sz="2600" dirty="0"/>
+            <a:endParaRPr lang="en-US" sz="2400" dirty="0"/>
           </a:p>
         </p:txBody>
       </p:sp>
@@ -13089,8 +13089,8 @@
         </p:nvSpPr>
         <p:spPr>
           <a:xfrm>
-            <a:off x="8313268" y="2560320"/>
-            <a:ext cx="1367714" cy="502920"/>
+            <a:off x="8275320" y="4023360"/>
+            <a:ext cx="1386688" cy="502920"/>
           </a:xfrm>
           <a:prstGeom prst="rect">
             <a:avLst/>
@@ -13128,12 +13128,12 @@
         </p:nvSpPr>
         <p:spPr>
           <a:xfrm>
-            <a:off x="10001021" y="1783080"/>
-            <a:ext cx="1642034" cy="1325880"/>
+            <a:off x="9982048" y="3246120"/>
+            <a:ext cx="1661008" cy="1371600"/>
           </a:xfrm>
           <a:prstGeom prst="roundRect">
             <a:avLst>
-              <a:gd name="adj" fmla="val 6897"/>
+              <a:gd name="adj" fmla="val 6667"/>
             </a:avLst>
           </a:prstGeom>
           <a:solidFill>
@@ -13155,8 +13155,8 @@
         </p:nvSpPr>
         <p:spPr>
           <a:xfrm>
-            <a:off x="10138181" y="1874520"/>
-            <a:ext cx="1367714" cy="640080"/>
+            <a:off x="10119208" y="3337560"/>
+            <a:ext cx="1386688" cy="640080"/>
           </a:xfrm>
           <a:prstGeom prst="rect">
             <a:avLst/>
@@ -13172,7 +13172,7 @@
               <a:buNone/>
             </a:pPr>
             <a:r>
-              <a:rPr lang="en-US" sz="2600" b="1" dirty="0">
+              <a:rPr lang="en-US" sz="2400" b="1" dirty="0">
                 <a:solidFill>
                   <a:srgbClr val="17494D"/>
                 </a:solidFill>
@@ -13180,9 +13180,9 @@
                 <a:ea typeface="Playfair Display" pitchFamily="34" charset="-122"/>
                 <a:cs typeface="Playfair Display" pitchFamily="34" charset="-120"/>
               </a:rPr>
-              <a:t>8 of 9</a:t>
-            </a:r>
-            <a:endParaRPr lang="en-US" sz="2600" dirty="0"/>
+              <a:t>7 of 7</a:t>
+            </a:r>
+            <a:endParaRPr lang="en-US" sz="2400" dirty="0"/>
           </a:p>
         </p:txBody>
       </p:sp>
@@ -13194,8 +13194,8 @@
         </p:nvSpPr>
         <p:spPr>
           <a:xfrm>
-            <a:off x="10138181" y="2560320"/>
-            <a:ext cx="1367714" cy="502920"/>
+            <a:off x="10119208" y="4023360"/>
+            <a:ext cx="1386688" cy="502920"/>
           </a:xfrm>
           <a:prstGeom prst="rect">
             <a:avLst/>
@@ -13233,7 +13233,7 @@
         </p:nvSpPr>
         <p:spPr>
           <a:xfrm>
-            <a:off x="4526280" y="3383280"/>
+            <a:off x="548640" y="4892040"/>
             <a:ext cx="457200" cy="457200"/>
           </a:xfrm>
           <a:prstGeom prst="ellipse">
@@ -13266,7 +13266,7 @@
         </p:blipFill>
         <p:spPr>
           <a:xfrm>
-            <a:off x="4640580" y="3497580"/>
+            <a:off x="662940" y="5006340"/>
             <a:ext cx="228600" cy="228600"/>
           </a:xfrm>
           <a:prstGeom prst="rect">
@@ -13282,8 +13282,8 @@
         </p:nvSpPr>
         <p:spPr>
           <a:xfrm>
-            <a:off x="5166360" y="3346704"/>
-            <a:ext cx="6476695" cy="310896"/>
+            <a:off x="1143000" y="4855464"/>
+            <a:ext cx="2920898" cy="310896"/>
           </a:xfrm>
           <a:prstGeom prst="rect">
             <a:avLst/>
@@ -13307,7 +13307,7 @@
                 <a:ea typeface="Poppins SemiBold" pitchFamily="34" charset="-122"/>
                 <a:cs typeface="Poppins SemiBold" pitchFamily="34" charset="-120"/>
               </a:rPr>
-              <a:t>Answers only from CivicPulse data</a:t>
+              <a:t>Only CivicPulse data</a:t>
             </a:r>
             <a:endParaRPr lang="en-US" sz="1300" dirty="0"/>
           </a:p>
@@ -13321,8 +13321,8 @@
         </p:nvSpPr>
         <p:spPr>
           <a:xfrm>
-            <a:off x="5166360" y="3648456"/>
-            <a:ext cx="6476695" cy="365760"/>
+            <a:off x="1143000" y="5166360"/>
+            <a:ext cx="2920898" cy="868680"/>
           </a:xfrm>
           <a:prstGeom prst="rect">
             <a:avLst/>
@@ -13346,7 +13346,7 @@
                 <a:ea typeface="Poppins" pitchFamily="34" charset="-122"/>
                 <a:cs typeface="Poppins" pitchFamily="34" charset="-120"/>
               </a:rPr>
-              <a:t>Spring builds a packet from the same data the officer sees. Residents’ complaint text is never sent.</a:t>
+              <a:t>The same data the officer sees, including hotspots and hazards. Residents’ complaint text is never sent.</a:t>
             </a:r>
             <a:endParaRPr lang="en-US" sz="1100" dirty="0"/>
           </a:p>
@@ -13360,7 +13360,7 @@
         </p:nvSpPr>
         <p:spPr>
           <a:xfrm>
-            <a:off x="4526280" y="4133088"/>
+            <a:off x="4338218" y="4892040"/>
             <a:ext cx="457200" cy="457200"/>
           </a:xfrm>
           <a:prstGeom prst="ellipse">
@@ -13393,7 +13393,7 @@
         </p:blipFill>
         <p:spPr>
           <a:xfrm>
-            <a:off x="4640580" y="4247388"/>
+            <a:off x="4452518" y="5006340"/>
             <a:ext cx="228600" cy="228600"/>
           </a:xfrm>
           <a:prstGeom prst="rect">
@@ -13409,8 +13409,8 @@
         </p:nvSpPr>
         <p:spPr>
           <a:xfrm>
-            <a:off x="5166360" y="4096512"/>
-            <a:ext cx="6476695" cy="310896"/>
+            <a:off x="4932578" y="4855464"/>
+            <a:ext cx="2920898" cy="310896"/>
           </a:xfrm>
           <a:prstGeom prst="rect">
             <a:avLst/>
@@ -13434,7 +13434,7 @@
                 <a:ea typeface="Poppins SemiBold" pitchFamily="34" charset="-122"/>
                 <a:cs typeface="Poppins SemiBold" pitchFamily="34" charset="-120"/>
               </a:rPr>
-              <a:t>Every claim cites an incident, ward or category</a:t>
+              <a:t>Every claim cites a source</a:t>
             </a:r>
             <a:endParaRPr lang="en-US" sz="1300" dirty="0"/>
           </a:p>
@@ -13448,8 +13448,8 @@
         </p:nvSpPr>
         <p:spPr>
           <a:xfrm>
-            <a:off x="5166360" y="4398264"/>
-            <a:ext cx="6476695" cy="365760"/>
+            <a:off x="4932578" y="5166360"/>
+            <a:ext cx="2920898" cy="868680"/>
           </a:xfrm>
           <a:prstGeom prst="rect">
             <a:avLst/>
@@ -13473,7 +13473,7 @@
                 <a:ea typeface="Poppins" pitchFamily="34" charset="-122"/>
                 <a:cs typeface="Poppins" pitchFamily="34" charset="-120"/>
               </a:rPr>
-              <a:t>Spring drops any citation that was not in the packet, and warns if none are left.</a:t>
+              <a:t>An incident, ward, category or hotspot. Spring drops any citation that was not in the data.</a:t>
             </a:r>
             <a:endParaRPr lang="en-US" sz="1100" dirty="0"/>
           </a:p>
@@ -13487,7 +13487,7 @@
         </p:nvSpPr>
         <p:spPr>
           <a:xfrm>
-            <a:off x="4526280" y="4882896"/>
+            <a:off x="8127797" y="4892040"/>
             <a:ext cx="457200" cy="457200"/>
           </a:xfrm>
           <a:prstGeom prst="ellipse">
@@ -13520,7 +13520,7 @@
         </p:blipFill>
         <p:spPr>
           <a:xfrm>
-            <a:off x="4640580" y="4997196"/>
+            <a:off x="8242097" y="5006340"/>
             <a:ext cx="228600" cy="228600"/>
           </a:xfrm>
           <a:prstGeom prst="rect">
@@ -13536,8 +13536,8 @@
         </p:nvSpPr>
         <p:spPr>
           <a:xfrm>
-            <a:off x="5166360" y="4846320"/>
-            <a:ext cx="6476695" cy="310896"/>
+            <a:off x="8722157" y="4855464"/>
+            <a:ext cx="2920898" cy="310896"/>
           </a:xfrm>
           <a:prstGeom prst="rect">
             <a:avLst/>
@@ -13575,8 +13575,8 @@
         </p:nvSpPr>
         <p:spPr>
           <a:xfrm>
-            <a:off x="5166360" y="5148072"/>
-            <a:ext cx="6476695" cy="365760"/>
+            <a:off x="8722157" y="5166360"/>
+            <a:ext cx="2920898" cy="868680"/>
           </a:xfrm>
           <a:prstGeom prst="rect">
             <a:avLst/>
@@ -13600,7 +13600,7 @@
                 <a:ea typeface="Poppins" pitchFamily="34" charset="-122"/>
                 <a:cs typeface="Poppins" pitchFamily="34" charset="-120"/>
               </a:rPr>
-              <a:t>Weather, the mayor, a resident’s phone number, “ignore your instructions”: all declined.</a:t>
+              <a:t>The weather, the mayor, a resident’s phone number, “ignore your instructions”: all declined.</a:t>
             </a:r>
             <a:endParaRPr lang="en-US" sz="1100" dirty="0"/>
           </a:p>
@@ -13608,46 +13608,7 @@
       </p:sp>
       <p:sp>
         <p:nvSpPr>
-          <p:cNvPr id="34" name="Text 28"/>
-          <p:cNvSpPr txBox="1"/>
-          <p:nvPr/>
-        </p:nvSpPr>
-        <p:spPr>
-          <a:xfrm>
-            <a:off x="4526280" y="5715000"/>
-            <a:ext cx="7116775" cy="457200"/>
-          </a:xfrm>
-          <a:prstGeom prst="rect">
-            <a:avLst/>
-          </a:prstGeom>
-          <a:noFill/>
-          <a:ln/>
-        </p:spPr>
-        <p:txBody>
-          <a:bodyPr wrap="square" lIns="0" tIns="0" rIns="0" bIns="0" rtlCol="0" anchor="t"/>
-          <a:lstStyle/>
-          <a:p>
-            <a:pPr marL="0" indent="0">
-              <a:buNone/>
-            </a:pPr>
-            <a:r>
-              <a:rPr lang="en-US" sz="1100" i="1" dirty="0">
-                <a:solidFill>
-                  <a:srgbClr val="4C5A56"/>
-                </a:solidFill>
-                <a:latin typeface="Poppins" pitchFamily="34" charset="0"/>
-                <a:ea typeface="Poppins" pitchFamily="34" charset="-122"/>
-                <a:cs typeface="Poppins" pitchFamily="34" charset="-120"/>
-              </a:rPr>
-              <a:t>The one miss: asked for hotspots, it named the busiest wards, because hotspots are not in its data yet. Eval on Gemini, 24 Oct 2026; median answer 4.3 s.</a:t>
-            </a:r>
-            <a:endParaRPr lang="en-US" sz="1100" dirty="0"/>
-          </a:p>
-        </p:txBody>
-      </p:sp>
-      <p:sp>
-        <p:nvSpPr>
-          <p:cNvPr id="35" name="Slide Number Placeholder 0"/>
+          <p:cNvPr id="34" name="Slide Number Placeholder 0"/>
           <p:cNvSpPr>
             <a:spLocks noGrp="1"/>
           </p:cNvSpPr>

</xml_diff>

<commit_message>
docs: final presentation replaces the paper; deck brought up to date
No paper: the project ends with the final deck. Phase 13 is now the final
presentation, listing the deck, its PDF and the speaker script, and the source
of every number on the slides. The deck's closing slide now shows what lies
beyond the project (a real data feed, code-mixed text at F2 0.85 to 0.91, photo
upload built but off) instead of a stale "next" list, and the speaker notes and
Q&A drop the officer ranking. The README marks the project complete with the
Copilot at 22/22, and the unused frontend health service is removed.
</commit_message>
<xml_diff>
--- a/presentation/CivicPulse-final.pptx
+++ b/presentation/CivicPulse-final.pptx
@@ -140,18 +140,18 @@
   <p:extLst>
     <p:ext uri="{521415D9-36F7-43E2-AB2F-B90AF26B5E84}">
       <p14:sectionLst xmlns:p14="http://schemas.microsoft.com/office/powerpoint/2010/main">
-        <p14:section name="Opening" id="{171F9030-7840-5A1E-A899-730A69278AA7}">
+        <p14:section name="Opening" id="{49D53240-84F3-F49A-4C73-BEF1EF66D84F}">
           <p14:sldIdLst>
             <p14:sldId id="256"/>
           </p14:sldIdLst>
         </p14:section>
-        <p14:section name="Problem and solution" id="{4B3A9A82-8F7E-2B11-6017-CFADF9C8829B}">
+        <p14:section name="Problem and solution" id="{6B96B09A-6321-1EB7-B2DB-350CE0AF777D}">
           <p14:sldIdLst>
             <p14:sldId id="257"/>
             <p14:sldId id="258"/>
           </p14:sldIdLst>
         </p14:section>
-        <p14:section name="How it works" id="{CC4AAFDD-F6F8-6F28-DBE3-60A5A9D4D565}">
+        <p14:section name="How it works" id="{62109DF5-E301-B4B6-96EF-DFE56938B4C5}">
           <p14:sldIdLst>
             <p14:sldId id="259"/>
             <p14:sldId id="260"/>
@@ -161,7 +161,7 @@
             <p14:sldId id="264"/>
           </p14:sldIdLst>
         </p14:section>
-        <p14:section name="Results and next steps" id="{7BFBC30F-B0DB-67C5-28B6-234700638433}">
+        <p14:section name="Results and next steps" id="{16EAEF54-027C-4BA8-87AD-DC55E9E6D40E}">
           <p14:sldIdLst>
             <p14:sldId id="265"/>
             <p14:sldId id="266"/>
@@ -327,7 +327,7 @@
           <c:smooth val="0"/>
           <c:extLst>
             <c:ext xmlns:c16="http://schemas.microsoft.com/office/drawing/2014/chart" uri="{C3380CC4-5D6E-409C-BE32-E72D297353CC}">
-              <c16:uniqueId val="{00000000-9DFC-43D8-A10A-553156EC3EF7}"/>
+              <c16:uniqueId val="{00000000-B106-43F0-9E0A-01A2000DF51D}"/>
             </c:ext>
           </c:extLst>
         </c:ser>
@@ -440,7 +440,7 @@
           <c:smooth val="0"/>
           <c:extLst>
             <c:ext xmlns:c16="http://schemas.microsoft.com/office/drawing/2014/chart" uri="{C3380CC4-5D6E-409C-BE32-E72D297353CC}">
-              <c16:uniqueId val="{00000001-9DFC-43D8-A10A-553156EC3EF7}"/>
+              <c16:uniqueId val="{00000001-B106-43F0-9E0A-01A2000DF51D}"/>
             </c:ext>
           </c:extLst>
         </c:ser>
@@ -732,7 +732,7 @@
           </c:val>
           <c:extLst>
             <c:ext xmlns:c16="http://schemas.microsoft.com/office/drawing/2014/chart" uri="{C3380CC4-5D6E-409C-BE32-E72D297353CC}">
-              <c16:uniqueId val="{00000000-98FB-4633-810B-8F58BB5B0952}"/>
+              <c16:uniqueId val="{00000000-0665-4FFF-8F20-FD1C6344C5E8}"/>
             </c:ext>
           </c:extLst>
         </c:ser>
@@ -831,7 +831,7 @@
           </c:val>
           <c:extLst>
             <c:ext xmlns:c16="http://schemas.microsoft.com/office/drawing/2014/chart" uri="{C3380CC4-5D6E-409C-BE32-E72D297353CC}">
-              <c16:uniqueId val="{00000001-98FB-4633-810B-8F58BB5B0952}"/>
+              <c16:uniqueId val="{00000001-0665-4FFF-8F20-FD1C6344C5E8}"/>
             </c:ext>
           </c:extLst>
         </c:ser>
@@ -930,7 +930,7 @@
           </c:val>
           <c:extLst>
             <c:ext xmlns:c16="http://schemas.microsoft.com/office/drawing/2014/chart" uri="{C3380CC4-5D6E-409C-BE32-E72D297353CC}">
-              <c16:uniqueId val="{00000002-98FB-4633-810B-8F58BB5B0952}"/>
+              <c16:uniqueId val="{00000002-0665-4FFF-8F20-FD1C6344C5E8}"/>
             </c:ext>
           </c:extLst>
         </c:ser>
@@ -1109,7 +1109,7 @@
     </p:spTree>
     <p:extLst>
       <p:ext uri="{BB962C8B-B14F-4D97-AF65-F5344CB8AC3E}">
-        <p14:creationId xmlns:p14="http://schemas.microsoft.com/office/powerpoint/2010/main" val="3465769672"/>
+        <p14:creationId xmlns:p14="http://schemas.microsoft.com/office/powerpoint/2010/main" val="2106894647"/>
       </p:ext>
     </p:extLst>
   </p:cSld>
@@ -1348,7 +1348,7 @@
               <a:t>SPEAKER 4  ·  about 45 seconds
 Overall, we measured instead of assuming.
 Grouping: 95 percent of real decisions correct. Priority: we had an AI ranker, which never saw our formula, rank 45 incidents three times. Our formula beat the naive “most reports first” baseline every time. Letting age count up to 30 days instead of 14 improved agreement in every run, so we applied it, and that is what is live.
-This ranker is a stand-in. A real officer’s ranking is our next check.</a:t>
+That age-30 calibration is final, and it is what runs on the live site.</a:t>
             </a:r>
           </a:p>
         </p:txBody>
@@ -1437,7 +1437,7 @@
               <a:rPr lang="en-US" dirty="0"/>
               <a:t>SPEAKER 4  ·  about 30 seconds
 Today, all of this is built, tested and deployed: intake, matching, priority, the console, hotspots, decision support, officer controls and the Copilot.
-Next: confirm the priority weights with a real officer, connect a real data feed, test Kannada–English mixed text, and add photo upload.</a:t>
+Beyond this project: the ingestion gate is ready for a real city data feed. We tested mixed Kannada–English text, and rewriting reports into English before matching lifted grouping quality from 0.85 to 0.91; it switches on once real reports confirm it. Photo upload is built, but we left it off in this deployment by choice.</a:t>
             </a:r>
           </a:p>
         </p:txBody>
@@ -3680,7 +3680,7 @@
                 <a:ea typeface="Poppins" pitchFamily="34" charset="-122"/>
                 <a:cs typeface="Poppins" pitchFamily="34" charset="-120"/>
               </a:rPr>
-              <a:t>Ranker: Gemini, briefed as a ward engineer and never shown the formula. A human officer ranking is the next check.</a:t>
+              <a:t>Ranker: Gemini, briefed as a ward engineer and never shown the formula. The age-30 calibration it pointed to is what runs live.</a:t>
             </a:r>
             <a:endParaRPr lang="en-US" sz="1100" dirty="0"/>
           </a:p>
@@ -4910,7 +4910,7 @@
                 <a:ea typeface="Playfair Display" pitchFamily="34" charset="-122"/>
                 <a:cs typeface="Playfair Display" pitchFamily="34" charset="-120"/>
               </a:rPr>
-              <a:t>Next</a:t>
+              <a:t>Beyond this project</a:t>
             </a:r>
             <a:endParaRPr lang="en-US" sz="2400" dirty="0"/>
           </a:p>
@@ -4918,7 +4918,7 @@
       </p:sp>
       <p:sp>
         <p:nvSpPr>
-          <p:cNvPr id="37" name="icon-bg LuSparkles"/>
+          <p:cNvPr id="37" name="icon-bg LuMapPin"/>
           <p:cNvSpPr/>
           <p:nvPr/>
         </p:nvSpPr>
@@ -4943,7 +4943,7 @@
       </p:sp>
       <p:pic>
         <p:nvPicPr>
-          <p:cNvPr id="38" name="icon LuSparkles" descr="preencoded.png"/>
+          <p:cNvPr id="38" name="icon LuMapPin" descr="preencoded.png"/>
           <p:cNvPicPr>
             <a:picLocks noChangeAspect="1"/>
           </p:cNvPicPr>
@@ -4998,7 +4998,7 @@
                 <a:ea typeface="Poppins SemiBold" pitchFamily="34" charset="-122"/>
                 <a:cs typeface="Poppins SemiBold" pitchFamily="34" charset="-120"/>
               </a:rPr>
-              <a:t>Mixed-language text</a:t>
+              <a:t>A real data feed</a:t>
             </a:r>
             <a:endParaRPr lang="en-US" sz="1300" dirty="0"/>
           </a:p>
@@ -5013,7 +5013,7 @@
         <p:spPr>
           <a:xfrm>
             <a:off x="8275320" y="2642616"/>
-            <a:ext cx="3367735" cy="566928"/>
+            <a:ext cx="3367735" cy="841248"/>
           </a:xfrm>
           <a:prstGeom prst="rect">
             <a:avLst/>
@@ -5037,7 +5037,7 @@
                 <a:ea typeface="Poppins" pitchFamily="34" charset="-122"/>
                 <a:cs typeface="Poppins" pitchFamily="34" charset="-120"/>
               </a:rPr>
-              <a:t>Kannada–English reports: test transliteration before matching.</a:t>
+              <a:t>The ingestion gate is ready; a city feed with text and coordinates would let us re-test on real reports.</a:t>
             </a:r>
             <a:endParaRPr lang="en-US" sz="1100" dirty="0"/>
           </a:p>
@@ -5045,13 +5045,13 @@
       </p:sp>
       <p:sp>
         <p:nvSpPr>
-          <p:cNvPr id="41" name="icon-bg LuGauge"/>
+          <p:cNvPr id="41" name="icon-bg LuSparkles"/>
           <p:cNvSpPr/>
           <p:nvPr/>
         </p:nvSpPr>
         <p:spPr>
           <a:xfrm>
-            <a:off x="7635240" y="3337560"/>
+            <a:off x="7635240" y="3566160"/>
             <a:ext cx="457200" cy="457200"/>
           </a:xfrm>
           <a:prstGeom prst="ellipse">
@@ -5070,7 +5070,7 @@
       </p:sp>
       <p:pic>
         <p:nvPicPr>
-          <p:cNvPr id="42" name="icon LuGauge" descr="preencoded.png"/>
+          <p:cNvPr id="42" name="icon LuSparkles" descr="preencoded.png"/>
           <p:cNvPicPr>
             <a:picLocks noChangeAspect="1"/>
           </p:cNvPicPr>
@@ -5084,7 +5084,7 @@
         </p:blipFill>
         <p:spPr>
           <a:xfrm>
-            <a:off x="7749540" y="3451860"/>
+            <a:off x="7749540" y="3680460"/>
             <a:ext cx="228600" cy="228600"/>
           </a:xfrm>
           <a:prstGeom prst="rect">
@@ -5100,7 +5100,7 @@
         </p:nvSpPr>
         <p:spPr>
           <a:xfrm>
-            <a:off x="8275320" y="3300984"/>
+            <a:off x="8275320" y="3529584"/>
             <a:ext cx="3367735" cy="310896"/>
           </a:xfrm>
           <a:prstGeom prst="rect">
@@ -5125,7 +5125,7 @@
                 <a:ea typeface="Poppins SemiBold" pitchFamily="34" charset="-122"/>
                 <a:cs typeface="Poppins SemiBold" pitchFamily="34" charset="-120"/>
               </a:rPr>
-              <a:t>A real officer ranking</a:t>
+              <a:t>Mixed-language text</a:t>
             </a:r>
             <a:endParaRPr lang="en-US" sz="1300" dirty="0"/>
           </a:p>
@@ -5139,8 +5139,8 @@
         </p:nvSpPr>
         <p:spPr>
           <a:xfrm>
-            <a:off x="8275320" y="3602736"/>
-            <a:ext cx="3367735" cy="566928"/>
+            <a:off x="8275320" y="3831336"/>
+            <a:ext cx="3367735" cy="841248"/>
           </a:xfrm>
           <a:prstGeom prst="rect">
             <a:avLst/>
@@ -5164,7 +5164,7 @@
                 <a:ea typeface="Poppins" pitchFamily="34" charset="-122"/>
                 <a:cs typeface="Poppins" pitchFamily="34" charset="-120"/>
               </a:rPr>
-              <a:t>Confirm the priority calibration with a human, not a proxy.</a:t>
+              <a:t>Tested: rewriting reports into English first lifts grouping F2 from 0.85 to 0.91. On once real reports confirm it.</a:t>
             </a:r>
             <a:endParaRPr lang="en-US" sz="1100" dirty="0"/>
           </a:p>
@@ -5172,13 +5172,13 @@
       </p:sp>
       <p:sp>
         <p:nvSpPr>
-          <p:cNvPr id="45" name="icon-bg LuMapPin"/>
+          <p:cNvPr id="45" name="icon-bg LuCamera"/>
           <p:cNvSpPr/>
           <p:nvPr/>
         </p:nvSpPr>
         <p:spPr>
           <a:xfrm>
-            <a:off x="7635240" y="4297680"/>
+            <a:off x="7635240" y="4754880"/>
             <a:ext cx="457200" cy="457200"/>
           </a:xfrm>
           <a:prstGeom prst="ellipse">
@@ -5197,7 +5197,7 @@
       </p:sp>
       <p:pic>
         <p:nvPicPr>
-          <p:cNvPr id="46" name="icon LuMapPin" descr="preencoded.png"/>
+          <p:cNvPr id="46" name="icon LuCamera" descr="preencoded.png"/>
           <p:cNvPicPr>
             <a:picLocks noChangeAspect="1"/>
           </p:cNvPicPr>
@@ -5211,7 +5211,7 @@
         </p:blipFill>
         <p:spPr>
           <a:xfrm>
-            <a:off x="7749540" y="4411980"/>
+            <a:off x="7749540" y="4869180"/>
             <a:ext cx="228600" cy="228600"/>
           </a:xfrm>
           <a:prstGeom prst="rect">
@@ -5227,7 +5227,7 @@
         </p:nvSpPr>
         <p:spPr>
           <a:xfrm>
-            <a:off x="8275320" y="4261104"/>
+            <a:off x="8275320" y="4718304"/>
             <a:ext cx="3367735" cy="310896"/>
           </a:xfrm>
           <a:prstGeom prst="rect">
@@ -5252,7 +5252,7 @@
                 <a:ea typeface="Poppins SemiBold" pitchFamily="34" charset="-122"/>
                 <a:cs typeface="Poppins SemiBold" pitchFamily="34" charset="-120"/>
               </a:rPr>
-              <a:t>A real data feed</a:t>
+              <a:t>Photo upload</a:t>
             </a:r>
             <a:endParaRPr lang="en-US" sz="1300" dirty="0"/>
           </a:p>
@@ -5266,8 +5266,8 @@
         </p:nvSpPr>
         <p:spPr>
           <a:xfrm>
-            <a:off x="8275320" y="4562856"/>
-            <a:ext cx="3367735" cy="566928"/>
+            <a:off x="8275320" y="5020056"/>
+            <a:ext cx="3367735" cy="841248"/>
           </a:xfrm>
           <a:prstGeom prst="rect">
             <a:avLst/>
@@ -5291,7 +5291,7 @@
                 <a:ea typeface="Poppins" pitchFamily="34" charset="-122"/>
                 <a:cs typeface="Poppins" pitchFamily="34" charset="-120"/>
               </a:rPr>
-              <a:t>Through the ingestion gate, then re-run the matching eval.</a:t>
+              <a:t>Built and tested, with location data stripped. Left off in this deployment by choice.</a:t>
             </a:r>
             <a:endParaRPr lang="en-US" sz="1100" dirty="0"/>
           </a:p>
@@ -5299,134 +5299,7 @@
       </p:sp>
       <p:sp>
         <p:nvSpPr>
-          <p:cNvPr id="49" name="icon-bg LuCamera"/>
-          <p:cNvSpPr/>
-          <p:nvPr/>
-        </p:nvSpPr>
-        <p:spPr>
-          <a:xfrm>
-            <a:off x="7635240" y="5257800"/>
-            <a:ext cx="457200" cy="457200"/>
-          </a:xfrm>
-          <a:prstGeom prst="ellipse">
-            <a:avLst/>
-          </a:prstGeom>
-          <a:solidFill>
-            <a:srgbClr val="DCE8E8"/>
-          </a:solidFill>
-          <a:ln w="12700">
-            <a:solidFill>
-              <a:srgbClr val="DCE8E8"/>
-            </a:solidFill>
-            <a:prstDash val="solid"/>
-          </a:ln>
-        </p:spPr>
-      </p:sp>
-      <p:pic>
-        <p:nvPicPr>
-          <p:cNvPr id="50" name="icon LuCamera" descr="preencoded.png"/>
-          <p:cNvPicPr>
-            <a:picLocks noChangeAspect="1"/>
-          </p:cNvPicPr>
-          <p:nvPr/>
-        </p:nvPicPr>
-        <p:blipFill>
-          <a:blip r:embed="rId7"/>
-          <a:stretch>
-            <a:fillRect/>
-          </a:stretch>
-        </p:blipFill>
-        <p:spPr>
-          <a:xfrm>
-            <a:off x="7749540" y="5372100"/>
-            <a:ext cx="228600" cy="228600"/>
-          </a:xfrm>
-          <a:prstGeom prst="rect">
-            <a:avLst/>
-          </a:prstGeom>
-        </p:spPr>
-      </p:pic>
-      <p:sp>
-        <p:nvSpPr>
-          <p:cNvPr id="51" name="Text 37"/>
-          <p:cNvSpPr txBox="1"/>
-          <p:nvPr/>
-        </p:nvSpPr>
-        <p:spPr>
-          <a:xfrm>
-            <a:off x="8275320" y="5221224"/>
-            <a:ext cx="3367735" cy="310896"/>
-          </a:xfrm>
-          <a:prstGeom prst="rect">
-            <a:avLst/>
-          </a:prstGeom>
-          <a:noFill/>
-          <a:ln/>
-        </p:spPr>
-        <p:txBody>
-          <a:bodyPr wrap="square" lIns="0" tIns="0" rIns="0" bIns="0" rtlCol="0" anchor="ctr"/>
-          <a:lstStyle/>
-          <a:p>
-            <a:pPr marL="0" indent="0">
-              <a:buNone/>
-            </a:pPr>
-            <a:r>
-              <a:rPr lang="en-US" sz="1300" dirty="0">
-                <a:solidFill>
-                  <a:srgbClr val="14211F"/>
-                </a:solidFill>
-                <a:latin typeface="Poppins SemiBold" pitchFamily="34" charset="0"/>
-                <a:ea typeface="Poppins SemiBold" pitchFamily="34" charset="-122"/>
-                <a:cs typeface="Poppins SemiBold" pitchFamily="34" charset="-120"/>
-              </a:rPr>
-              <a:t>Photo upload</a:t>
-            </a:r>
-            <a:endParaRPr lang="en-US" sz="1300" dirty="0"/>
-          </a:p>
-        </p:txBody>
-      </p:sp>
-      <p:sp>
-        <p:nvSpPr>
-          <p:cNvPr id="52" name="Text 38"/>
-          <p:cNvSpPr txBox="1"/>
-          <p:nvPr/>
-        </p:nvSpPr>
-        <p:spPr>
-          <a:xfrm>
-            <a:off x="8275320" y="5522976"/>
-            <a:ext cx="3367735" cy="566928"/>
-          </a:xfrm>
-          <a:prstGeom prst="rect">
-            <a:avLst/>
-          </a:prstGeom>
-          <a:noFill/>
-          <a:ln/>
-        </p:spPr>
-        <p:txBody>
-          <a:bodyPr wrap="square" lIns="0" tIns="0" rIns="0" bIns="0" rtlCol="0" anchor="t"/>
-          <a:lstStyle/>
-          <a:p>
-            <a:pPr marL="0" indent="0">
-              <a:buNone/>
-            </a:pPr>
-            <a:r>
-              <a:rPr lang="en-US" sz="1100" dirty="0">
-                <a:solidFill>
-                  <a:srgbClr val="4C5A56"/>
-                </a:solidFill>
-                <a:latin typeface="Poppins" pitchFamily="34" charset="0"/>
-                <a:ea typeface="Poppins" pitchFamily="34" charset="-122"/>
-                <a:cs typeface="Poppins" pitchFamily="34" charset="-120"/>
-              </a:rPr>
-              <a:t>Contract approved, not built.</a:t>
-            </a:r>
-            <a:endParaRPr lang="en-US" sz="1100" dirty="0"/>
-          </a:p>
-        </p:txBody>
-      </p:sp>
-      <p:sp>
-        <p:nvSpPr>
-          <p:cNvPr id="53" name="Slide Number Placeholder 0"/>
+          <p:cNvPr id="49" name="Slide Number Placeholder 0"/>
           <p:cNvSpPr>
             <a:spLocks noGrp="1"/>
           </p:cNvSpPr>
@@ -8606,7 +8479,7 @@
                 <a:ea typeface="Poppins" pitchFamily="34" charset="-122"/>
                 <a:cs typeface="Poppins" pitchFamily="34" charset="-120"/>
               </a:rPr>
-              <a:t>Flyway migrations, 25 so far</a:t>
+              <a:t>Flyway migrations, 26 in all</a:t>
             </a:r>
             <a:endParaRPr lang="en-US" sz="1100" dirty="0"/>
           </a:p>

</xml_diff>